<commit_message>
Add EWS dataset and clean up repo for demo
- Add data/ews/ (train/validation/test splits, 380 files) so the demo
  can be run after a plain git clone without a separate data transfer
- Update .gitignore: remove data/ews exclusion; ignore vision_pro_code/,
  reports/*.pdf, reports/修改.md, and submission_code.zip
- Update reports/COMP9517_Presentation.pptx

Co-Authored-By: Claude Sonnet 4.6 <noreply@anthropic.com>
</commit_message>
<xml_diff>
--- a/reports/COMP9517_Presentation.pptx
+++ b/reports/COMP9517_Presentation.pptx
@@ -5,7 +5,7 @@
     <p:sldMasterId id="2147483648" r:id="rId1"/>
   </p:sldMasterIdLst>
   <p:notesMasterIdLst>
-    <p:notesMasterId r:id="rId19"/>
+    <p:notesMasterId r:id="rId18"/>
   </p:notesMasterIdLst>
   <p:sldIdLst>
     <p:sldId id="256" r:id="rId2"/>
@@ -24,7 +24,6 @@
     <p:sldId id="268" r:id="rId15"/>
     <p:sldId id="269" r:id="rId16"/>
     <p:sldId id="270" r:id="rId17"/>
-    <p:sldId id="271" r:id="rId18"/>
   </p:sldIdLst>
   <p:sldSz cx="9144000" cy="5143500" type="screen16x9"/>
   <p:notesSz cx="5143500" cy="9144000"/>
@@ -1709,6 +1708,13 @@
           </p:nvPr>
         </p:nvSpPr>
         <p:spPr/>
+        <p:txBody>
+          <a:bodyPr/>
+          <a:lstStyle/>
+          <a:p>
+            <a:endParaRPr lang="en-CN"/>
+          </a:p>
+        </p:txBody>
       </p:sp>
       <p:sp>
         <p:nvSpPr>
@@ -1793,6 +1799,13 @@
           </p:nvPr>
         </p:nvSpPr>
         <p:spPr/>
+        <p:txBody>
+          <a:bodyPr/>
+          <a:lstStyle/>
+          <a:p>
+            <a:endParaRPr lang="en-CN"/>
+          </a:p>
+        </p:txBody>
       </p:sp>
       <p:sp>
         <p:nvSpPr>
@@ -1877,6 +1890,13 @@
           </p:nvPr>
         </p:nvSpPr>
         <p:spPr/>
+        <p:txBody>
+          <a:bodyPr/>
+          <a:lstStyle/>
+          <a:p>
+            <a:endParaRPr lang="en-CN"/>
+          </a:p>
+        </p:txBody>
       </p:sp>
       <p:sp>
         <p:nvSpPr>
@@ -1961,6 +1981,13 @@
           </p:nvPr>
         </p:nvSpPr>
         <p:spPr/>
+        <p:txBody>
+          <a:bodyPr/>
+          <a:lstStyle/>
+          <a:p>
+            <a:endParaRPr lang="en-CN"/>
+          </a:p>
+        </p:txBody>
       </p:sp>
       <p:sp>
         <p:nvSpPr>
@@ -2045,6 +2072,13 @@
           </p:nvPr>
         </p:nvSpPr>
         <p:spPr/>
+        <p:txBody>
+          <a:bodyPr/>
+          <a:lstStyle/>
+          <a:p>
+            <a:endParaRPr lang="en-CN"/>
+          </a:p>
+        </p:txBody>
       </p:sp>
       <p:sp>
         <p:nvSpPr>
@@ -2129,6 +2163,13 @@
           </p:nvPr>
         </p:nvSpPr>
         <p:spPr/>
+        <p:txBody>
+          <a:bodyPr/>
+          <a:lstStyle/>
+          <a:p>
+            <a:endParaRPr lang="en-CN"/>
+          </a:p>
+        </p:txBody>
       </p:sp>
       <p:sp>
         <p:nvSpPr>
@@ -2213,6 +2254,13 @@
           </p:nvPr>
         </p:nvSpPr>
         <p:spPr/>
+        <p:txBody>
+          <a:bodyPr/>
+          <a:lstStyle/>
+          <a:p>
+            <a:endParaRPr lang="en-CN"/>
+          </a:p>
+        </p:txBody>
       </p:sp>
       <p:sp>
         <p:nvSpPr>
@@ -2251,90 +2299,6 @@
             <a:fld id="{F7021451-1387-4CA6-816F-3879F97B5CBC}" type="slidenum">
               <a:rPr lang="en-US"/>
               <a:t>16</a:t>
-            </a:fld>
-            <a:endParaRPr lang="en-US"/>
-          </a:p>
-        </p:txBody>
-      </p:sp>
-    </p:spTree>
-    <p:extLst>
-      <p:ext uri="{BB962C8B-B14F-4D97-AF65-F5344CB8AC3E}">
-        <p14:creationId xmlns:p14="http://schemas.microsoft.com/office/powerpoint/2010/main" val="1024086991"/>
-      </p:ext>
-    </p:extLst>
-  </p:cSld>
-  <p:clrMapOvr>
-    <a:masterClrMapping/>
-  </p:clrMapOvr>
-</p:notes>
-</file>
-
-<file path=ppt/notesSlides/notesSlide16.xml><?xml version="1.0" encoding="utf-8"?>
-<p:notes xmlns:a="http://schemas.openxmlformats.org/drawingml/2006/main" xmlns:r="http://schemas.openxmlformats.org/officeDocument/2006/relationships" xmlns:p="http://schemas.openxmlformats.org/presentationml/2006/main">
-  <p:cSld>
-    <p:spTree>
-      <p:nvGrpSpPr>
-        <p:cNvPr id="1" name=""/>
-        <p:cNvGrpSpPr/>
-        <p:nvPr/>
-      </p:nvGrpSpPr>
-      <p:grpSpPr>
-        <a:xfrm>
-          <a:off x="0" y="0"/>
-          <a:ext cx="0" cy="0"/>
-          <a:chOff x="0" y="0"/>
-          <a:chExt cx="0" cy="0"/>
-        </a:xfrm>
-      </p:grpSpPr>
-      <p:sp>
-        <p:nvSpPr>
-          <p:cNvPr id="2" name="Slide Image Placeholder 1"/>
-          <p:cNvSpPr>
-            <a:spLocks noGrp="1" noRot="1" noChangeAspect="1"/>
-          </p:cNvSpPr>
-          <p:nvPr>
-            <p:ph type="sldImg"/>
-          </p:nvPr>
-        </p:nvSpPr>
-        <p:spPr/>
-      </p:sp>
-      <p:sp>
-        <p:nvSpPr>
-          <p:cNvPr id="3" name="Notes Placeholder 2"/>
-          <p:cNvSpPr>
-            <a:spLocks noGrp="1"/>
-          </p:cNvSpPr>
-          <p:nvPr>
-            <p:ph type="body" idx="1"/>
-          </p:nvPr>
-        </p:nvSpPr>
-        <p:spPr/>
-        <p:txBody>
-          <a:bodyPr/>
-          <a:lstStyle/>
-          <a:p>
-            <a:endParaRPr lang="en-US" dirty="0"/>
-          </a:p>
-        </p:txBody>
-      </p:sp>
-      <p:sp>
-        <p:nvSpPr>
-          <p:cNvPr id="4" name="Slide Number Placeholder 3"/>
-          <p:cNvSpPr>
-            <a:spLocks noGrp="1"/>
-          </p:cNvSpPr>
-          <p:nvPr>
-            <p:ph type="sldNum" sz="quarter" idx="10"/>
-          </p:nvPr>
-        </p:nvSpPr>
-        <p:spPr/>
-        <p:txBody>
-          <a:bodyPr/>
-          <a:lstStyle/>
-          <a:p>
-            <a:fld id="{F7021451-1387-4CA6-816F-3879F97B5CBC}" type="slidenum">
-              <a:rPr lang="en-US"/>
-              <a:t>17</a:t>
             </a:fld>
             <a:endParaRPr lang="en-US"/>
           </a:p>
@@ -2381,6 +2345,13 @@
           </p:nvPr>
         </p:nvSpPr>
         <p:spPr/>
+        <p:txBody>
+          <a:bodyPr/>
+          <a:lstStyle/>
+          <a:p>
+            <a:endParaRPr lang="en-CN"/>
+          </a:p>
+        </p:txBody>
       </p:sp>
       <p:sp>
         <p:nvSpPr>
@@ -2465,6 +2436,13 @@
           </p:nvPr>
         </p:nvSpPr>
         <p:spPr/>
+        <p:txBody>
+          <a:bodyPr/>
+          <a:lstStyle/>
+          <a:p>
+            <a:endParaRPr lang="en-CN"/>
+          </a:p>
+        </p:txBody>
       </p:sp>
       <p:sp>
         <p:nvSpPr>
@@ -2549,6 +2527,13 @@
           </p:nvPr>
         </p:nvSpPr>
         <p:spPr/>
+        <p:txBody>
+          <a:bodyPr/>
+          <a:lstStyle/>
+          <a:p>
+            <a:endParaRPr lang="en-CN"/>
+          </a:p>
+        </p:txBody>
       </p:sp>
       <p:sp>
         <p:nvSpPr>
@@ -2633,6 +2618,13 @@
           </p:nvPr>
         </p:nvSpPr>
         <p:spPr/>
+        <p:txBody>
+          <a:bodyPr/>
+          <a:lstStyle/>
+          <a:p>
+            <a:endParaRPr lang="en-CN"/>
+          </a:p>
+        </p:txBody>
       </p:sp>
       <p:sp>
         <p:nvSpPr>
@@ -2717,6 +2709,13 @@
           </p:nvPr>
         </p:nvSpPr>
         <p:spPr/>
+        <p:txBody>
+          <a:bodyPr/>
+          <a:lstStyle/>
+          <a:p>
+            <a:endParaRPr lang="en-CN"/>
+          </a:p>
+        </p:txBody>
       </p:sp>
       <p:sp>
         <p:nvSpPr>
@@ -2801,6 +2800,13 @@
           </p:nvPr>
         </p:nvSpPr>
         <p:spPr/>
+        <p:txBody>
+          <a:bodyPr/>
+          <a:lstStyle/>
+          <a:p>
+            <a:endParaRPr lang="en-CN"/>
+          </a:p>
+        </p:txBody>
       </p:sp>
       <p:sp>
         <p:nvSpPr>
@@ -2885,6 +2891,13 @@
           </p:nvPr>
         </p:nvSpPr>
         <p:spPr/>
+        <p:txBody>
+          <a:bodyPr/>
+          <a:lstStyle/>
+          <a:p>
+            <a:endParaRPr lang="en-CN"/>
+          </a:p>
+        </p:txBody>
       </p:sp>
       <p:sp>
         <p:nvSpPr>
@@ -2969,6 +2982,13 @@
           </p:nvPr>
         </p:nvSpPr>
         <p:spPr/>
+        <p:txBody>
+          <a:bodyPr/>
+          <a:lstStyle/>
+          <a:p>
+            <a:endParaRPr lang="en-CN"/>
+          </a:p>
+        </p:txBody>
       </p:sp>
       <p:sp>
         <p:nvSpPr>
@@ -3538,38 +3558,6 @@
       </p:sp>
       <p:sp>
         <p:nvSpPr>
-          <p:cNvPr id="7" name="Shape 5"/>
-          <p:cNvSpPr/>
-          <p:nvPr/>
-        </p:nvSpPr>
-        <p:spPr>
-          <a:xfrm>
-            <a:off x="457200" y="2606040"/>
-            <a:ext cx="4114800" cy="36576"/>
-          </a:xfrm>
-          <a:prstGeom prst="rect">
-            <a:avLst/>
-          </a:prstGeom>
-          <a:solidFill>
-            <a:srgbClr val="52B788"/>
-          </a:solidFill>
-          <a:ln w="12700">
-            <a:solidFill>
-              <a:srgbClr val="52B788"/>
-            </a:solidFill>
-            <a:prstDash val="solid"/>
-          </a:ln>
-        </p:spPr>
-        <p:txBody>
-          <a:bodyPr/>
-          <a:lstStyle/>
-          <a:p>
-            <a:endParaRPr lang="en-CN"/>
-          </a:p>
-        </p:txBody>
-      </p:sp>
-      <p:sp>
-        <p:nvSpPr>
           <p:cNvPr id="8" name="Text 6"/>
           <p:cNvSpPr/>
           <p:nvPr/>
@@ -4227,7 +4215,7 @@
                 <a:ea typeface="Calibri" pitchFamily="34" charset="-122"/>
                 <a:cs typeface="Calibri" pitchFamily="34" charset="-120"/>
               </a:rPr>
-              <a:t>False alarm rate</a:t>
+              <a:t>Positive predictive value</a:t>
             </a:r>
             <a:endParaRPr lang="en-US" sz="1000" dirty="0"/>
           </a:p>
@@ -6474,10 +6462,16 @@
           <p:cNvGraphicFramePr>
             <a:graphicFrameLocks noGrp="1"/>
           </p:cNvGraphicFramePr>
-          <p:nvPr/>
+          <p:nvPr>
+            <p:extLst>
+              <p:ext uri="{D42A27DB-BD31-4B8C-83A1-F6EECF244321}">
+                <p14:modId xmlns:p14="http://schemas.microsoft.com/office/powerpoint/2010/main" val="3082676683"/>
+              </p:ext>
+            </p:extLst>
+          </p:nvPr>
         </p:nvGraphicFramePr>
         <p:xfrm>
-          <a:off x="274320" y="822960"/>
+          <a:off x="826241" y="1290268"/>
           <a:ext cx="3380000" cy="1600000"/>
         </p:xfrm>
         <a:graphic>
@@ -7309,7 +7303,7 @@
         <p:spPr>
           <a:xfrm>
             <a:off x="4937760" y="3035160"/>
-            <a:ext cx="4069080" cy="548640"/>
+            <a:ext cx="4069080" cy="461665"/>
           </a:xfrm>
           <a:prstGeom prst="rect">
             <a:avLst/>
@@ -7324,14 +7318,92 @@
           <a:p>
             <a:pPr algn="l"/>
             <a:r>
-              <a:rPr sz="1200" b="0">
+              <a:rPr sz="1200" b="0" dirty="0">
                 <a:solidFill>
                   <a:srgbClr val="333333"/>
                 </a:solidFill>
               </a:rPr>
-              <a:t>▸  Cause: dense May canopy raises
-   background ExG; Watershed seeds
-   become unreliable</a:t>
+              <a:t>▸  Cause: dense May canopy raises</a:t>
+            </a:r>
+            <a:r>
+              <a:rPr lang="zh-CN" altLang="en-US" sz="1200" dirty="0">
+                <a:solidFill>
+                  <a:srgbClr val="333333"/>
+                </a:solidFill>
+              </a:rPr>
+              <a:t> </a:t>
+            </a:r>
+            <a:r>
+              <a:rPr sz="1200" b="0" dirty="0">
+                <a:solidFill>
+                  <a:srgbClr val="333333"/>
+                </a:solidFill>
+              </a:rPr>
+              <a:t>background </a:t>
+            </a:r>
+            <a:r>
+              <a:rPr sz="1200" b="0" dirty="0" err="1">
+                <a:solidFill>
+                  <a:srgbClr val="333333"/>
+                </a:solidFill>
+              </a:rPr>
+              <a:t>ExG</a:t>
+            </a:r>
+            <a:r>
+              <a:rPr sz="1200" b="0" dirty="0">
+                <a:solidFill>
+                  <a:srgbClr val="333333"/>
+                </a:solidFill>
+              </a:rPr>
+              <a:t>; </a:t>
+            </a:r>
+            <a:r>
+              <a:rPr lang="zh-CN" altLang="en-US" sz="1200" dirty="0">
+                <a:solidFill>
+                  <a:srgbClr val="333333"/>
+                </a:solidFill>
+              </a:rPr>
+              <a:t>    </a:t>
+            </a:r>
+            <a:endParaRPr lang="en-US" altLang="zh-CN" sz="1200" dirty="0">
+              <a:solidFill>
+                <a:srgbClr val="333333"/>
+              </a:solidFill>
+            </a:endParaRPr>
+          </a:p>
+          <a:p>
+            <a:pPr algn="l"/>
+            <a:r>
+              <a:rPr lang="zh-CN" altLang="en-US" sz="1200" b="0" dirty="0">
+                <a:solidFill>
+                  <a:srgbClr val="333333"/>
+                </a:solidFill>
+              </a:rPr>
+              <a:t>  </a:t>
+            </a:r>
+            <a:r>
+              <a:rPr sz="1200" b="0" dirty="0">
+                <a:solidFill>
+                  <a:srgbClr val="333333"/>
+                </a:solidFill>
+              </a:rPr>
+              <a:t>Watershed seeds</a:t>
+            </a:r>
+            <a:r>
+              <a:rPr lang="zh-CN" altLang="en-US" sz="1200" dirty="0">
+                <a:solidFill>
+                  <a:srgbClr val="333333"/>
+                </a:solidFill>
+              </a:rPr>
+              <a:t> </a:t>
+            </a:r>
+            <a:r>
+              <a:rPr sz="1200" b="0" dirty="0">
+                <a:solidFill>
+                  <a:srgbClr val="333333"/>
+                </a:solidFill>
+              </a:rPr>
+              <a:t>become unreliable</a:t>
             </a:r>
           </a:p>
         </p:txBody>
@@ -7345,7 +7417,7 @@
         <p:spPr>
           <a:xfrm>
             <a:off x="4937760" y="3620160"/>
-            <a:ext cx="4069080" cy="548640"/>
+            <a:ext cx="4069080" cy="461665"/>
           </a:xfrm>
           <a:prstGeom prst="rect">
             <a:avLst/>
@@ -7360,15 +7432,98 @@
           <a:p>
             <a:pPr algn="l"/>
             <a:r>
-              <a:rPr sz="1200" b="0">
+              <a:rPr sz="1200" b="0" dirty="0">
                 <a:solidFill>
                   <a:srgbClr val="333333"/>
                 </a:solidFill>
               </a:rPr>
-              <a:t>▸  Training has NO May images —
-   learning-based methods still
-   generalise above IoU 0.76</a:t>
-            </a:r>
+              <a:t>▸  Training has NO May images —</a:t>
+            </a:r>
+            <a:r>
+              <a:rPr lang="en-CN" sz="1200" b="0" dirty="0">
+                <a:solidFill>
+                  <a:srgbClr val="333333"/>
+                </a:solidFill>
+              </a:rPr>
+              <a:t> </a:t>
+            </a:r>
+            <a:r>
+              <a:rPr sz="1200" b="0" dirty="0">
+                <a:solidFill>
+                  <a:srgbClr val="333333"/>
+                </a:solidFill>
+              </a:rPr>
+              <a:t>learning-based methods </a:t>
+            </a:r>
+            <a:r>
+              <a:rPr lang="zh-CN" altLang="en-US" sz="1200" b="0" dirty="0">
+                <a:solidFill>
+                  <a:srgbClr val="333333"/>
+                </a:solidFill>
+              </a:rPr>
+              <a:t>         </a:t>
+            </a:r>
+            <a:r>
+              <a:rPr lang="en-US" sz="1200" b="0" dirty="0">
+                <a:solidFill>
+                  <a:srgbClr val="333333"/>
+                </a:solidFill>
+              </a:rPr>
+              <a:t>still</a:t>
+            </a:r>
+            <a:r>
+              <a:rPr lang="zh-CN" altLang="en-US" sz="1200" dirty="0">
+                <a:solidFill>
+                  <a:srgbClr val="333333"/>
+                </a:solidFill>
+              </a:rPr>
+              <a:t> </a:t>
+            </a:r>
+            <a:r>
+              <a:rPr sz="1200" b="0" dirty="0" err="1">
+                <a:solidFill>
+                  <a:srgbClr val="333333"/>
+                </a:solidFill>
+              </a:rPr>
+              <a:t>generalise</a:t>
+            </a:r>
+            <a:r>
+              <a:rPr sz="1200" b="0" dirty="0">
+                <a:solidFill>
+                  <a:srgbClr val="333333"/>
+                </a:solidFill>
+              </a:rPr>
+              <a:t> above </a:t>
+            </a:r>
+            <a:r>
+              <a:rPr sz="1200" b="0" dirty="0" err="1">
+                <a:solidFill>
+                  <a:srgbClr val="333333"/>
+                </a:solidFill>
+              </a:rPr>
+              <a:t>IoU</a:t>
+            </a:r>
+            <a:r>
+              <a:rPr sz="1200" b="0" dirty="0">
+                <a:solidFill>
+                  <a:srgbClr val="333333"/>
+                </a:solidFill>
+              </a:rPr>
+              <a:t> 0.76</a:t>
+            </a:r>
+            <a:r>
+              <a:rPr lang="en-US" sz="1200" b="0" dirty="0">
+                <a:solidFill>
+                  <a:srgbClr val="333333"/>
+                </a:solidFill>
+              </a:rPr>
+              <a:t>	</a:t>
+            </a:r>
+            <a:endParaRPr sz="1200" b="0" dirty="0">
+              <a:solidFill>
+                <a:srgbClr val="333333"/>
+              </a:solidFill>
+            </a:endParaRPr>
           </a:p>
         </p:txBody>
       </p:sp>
@@ -7380,7 +7535,7 @@
         </p:nvSpPr>
         <p:spPr>
           <a:xfrm>
-            <a:off x="274320" y="2605000"/>
+            <a:off x="276241" y="3563718"/>
             <a:ext cx="4480000" cy="320000"/>
           </a:xfrm>
           <a:prstGeom prst="rect">
@@ -7414,7 +7569,7 @@
           <a:lstStyle/>
           <a:p>
             <a:pPr algn="ctr"/>
-            <a:endParaRPr/>
+            <a:endParaRPr dirty="0"/>
           </a:p>
         </p:txBody>
       </p:sp>
@@ -7426,7 +7581,7 @@
         </p:nvSpPr>
         <p:spPr>
           <a:xfrm>
-            <a:off x="320000" y="2605000"/>
+            <a:off x="365760" y="3583800"/>
             <a:ext cx="4400000" cy="320000"/>
           </a:xfrm>
           <a:prstGeom prst="rect">
@@ -7442,12 +7597,28 @@
           <a:p>
             <a:pPr algn="l"/>
             <a:r>
-              <a:rPr sz="1100" b="0">
+              <a:rPr sz="1100" b="0" dirty="0">
                 <a:solidFill>
                   <a:srgbClr val="B71C1C"/>
                 </a:solidFill>
               </a:rPr>
-              <a:t>⚠  Worst May image (20170505):  M1 IoU = 0.086  (near-total failure)</a:t>
+              <a:t>⚠  Worst May image (20170505):  M1 </a:t>
+            </a:r>
+            <a:r>
+              <a:rPr sz="1100" b="0" dirty="0" err="1">
+                <a:solidFill>
+                  <a:srgbClr val="B71C1C"/>
+                </a:solidFill>
+              </a:rPr>
+              <a:t>IoU</a:t>
+            </a:r>
+            <a:r>
+              <a:rPr sz="1100" b="0" dirty="0">
+                <a:solidFill>
+                  <a:srgbClr val="B71C1C"/>
+                </a:solidFill>
+              </a:rPr>
+              <a:t> = 0.086  (near-total failure)</a:t>
             </a:r>
           </a:p>
         </p:txBody>
@@ -7649,7 +7820,7 @@
                 <a:ea typeface="Calibri" pitchFamily="34" charset="-122"/>
                 <a:cs typeface="Calibri" pitchFamily="34" charset="-120"/>
               </a:rPr>
-              <a:t>M3 drops 0.874→0.596 on low-contrast ×0.4  |  M3-R (orange) trained with distortion augmentation recovers to 0.762  (+0.166)</a:t>
+              <a:t>M3 drops 0.874→0.596 on low-contrast ×0.4  |  M3-R recovers to 0.762 (+0.166)  |  M1 improves under noise (0.415→0.541) but drops under blur</a:t>
             </a:r>
             <a:endParaRPr lang="en-US" sz="1000" dirty="0"/>
           </a:p>
@@ -7985,7 +8156,7 @@
                 <a:ea typeface="Calibri" pitchFamily="34" charset="-122"/>
                 <a:cs typeface="Calibri" pitchFamily="34" charset="-120"/>
               </a:rPr>
-              <a:t>Diminishing returns beyond 50% for both supervised methods</a:t>
+              <a:t>M3 shows diminishing returns beyond 50%; M2 dips at 50% due to sample variance</a:t>
             </a:r>
             <a:endParaRPr lang="en-US" sz="1000" dirty="0"/>
           </a:p>
@@ -9475,808 +9646,6 @@
 </p:sld>
 </file>
 
-<file path=ppt/slides/slide17.xml><?xml version="1.0" encoding="utf-8"?>
-<p:sld xmlns:a="http://schemas.openxmlformats.org/drawingml/2006/main" xmlns:r="http://schemas.openxmlformats.org/officeDocument/2006/relationships" xmlns:p="http://schemas.openxmlformats.org/presentationml/2006/main">
-  <p:cSld name="Slide 16">
-    <p:bg>
-      <p:bgPr>
-        <a:solidFill>
-          <a:srgbClr val="1A1A2E"/>
-        </a:solidFill>
-        <a:effectLst/>
-      </p:bgPr>
-    </p:bg>
-    <p:spTree>
-      <p:nvGrpSpPr>
-        <p:cNvPr id="1" name=""/>
-        <p:cNvGrpSpPr/>
-        <p:nvPr/>
-      </p:nvGrpSpPr>
-      <p:grpSpPr>
-        <a:xfrm>
-          <a:off x="0" y="0"/>
-          <a:ext cx="0" cy="0"/>
-          <a:chOff x="0" y="0"/>
-          <a:chExt cx="0" cy="0"/>
-        </a:xfrm>
-      </p:grpSpPr>
-      <p:sp>
-        <p:nvSpPr>
-          <p:cNvPr id="2" name="Shape 0"/>
-          <p:cNvSpPr/>
-          <p:nvPr/>
-        </p:nvSpPr>
-        <p:spPr>
-          <a:xfrm>
-            <a:off x="0" y="0"/>
-            <a:ext cx="9144000" cy="685800"/>
-          </a:xfrm>
-          <a:prstGeom prst="rect">
-            <a:avLst/>
-          </a:prstGeom>
-          <a:solidFill>
-            <a:srgbClr val="52B788"/>
-          </a:solidFill>
-          <a:ln w="12700">
-            <a:solidFill>
-              <a:srgbClr val="52B788"/>
-            </a:solidFill>
-            <a:prstDash val="solid"/>
-          </a:ln>
-        </p:spPr>
-        <p:txBody>
-          <a:bodyPr/>
-          <a:lstStyle/>
-          <a:p>
-            <a:endParaRPr lang="en-CN"/>
-          </a:p>
-        </p:txBody>
-      </p:sp>
-      <p:sp>
-        <p:nvSpPr>
-          <p:cNvPr id="3" name="Text 1"/>
-          <p:cNvSpPr/>
-          <p:nvPr/>
-        </p:nvSpPr>
-        <p:spPr>
-          <a:xfrm>
-            <a:off x="365760" y="0"/>
-            <a:ext cx="8229600" cy="685800"/>
-          </a:xfrm>
-          <a:prstGeom prst="rect">
-            <a:avLst/>
-          </a:prstGeom>
-          <a:noFill/>
-          <a:ln/>
-        </p:spPr>
-        <p:txBody>
-          <a:bodyPr wrap="square" lIns="0" tIns="0" rIns="0" bIns="0" rtlCol="0" anchor="ctr"/>
-          <a:lstStyle/>
-          <a:p>
-            <a:pPr marL="0" indent="0">
-              <a:buNone/>
-            </a:pPr>
-            <a:r>
-              <a:rPr lang="en-US" sz="2800" b="1" dirty="0">
-                <a:solidFill>
-                  <a:srgbClr val="1A1A2E"/>
-                </a:solidFill>
-                <a:latin typeface="Calibri" pitchFamily="34" charset="0"/>
-                <a:ea typeface="Calibri" pitchFamily="34" charset="-122"/>
-                <a:cs typeface="Calibri" pitchFamily="34" charset="-120"/>
-              </a:rPr>
-              <a:t>DEMO</a:t>
-            </a:r>
-            <a:endParaRPr lang="en-US" sz="2800" dirty="0"/>
-          </a:p>
-        </p:txBody>
-      </p:sp>
-      <p:sp>
-        <p:nvSpPr>
-          <p:cNvPr id="4" name="Shape 2"/>
-          <p:cNvSpPr/>
-          <p:nvPr/>
-        </p:nvSpPr>
-        <p:spPr>
-          <a:xfrm>
-            <a:off x="365760" y="822960"/>
-            <a:ext cx="5212080" cy="804672"/>
-          </a:xfrm>
-          <a:prstGeom prst="rect">
-            <a:avLst/>
-          </a:prstGeom>
-          <a:solidFill>
-            <a:srgbClr val="0F2419"/>
-          </a:solidFill>
-          <a:ln w="12700">
-            <a:solidFill>
-              <a:srgbClr val="333333"/>
-            </a:solidFill>
-            <a:prstDash val="solid"/>
-          </a:ln>
-        </p:spPr>
-        <p:txBody>
-          <a:bodyPr/>
-          <a:lstStyle/>
-          <a:p>
-            <a:endParaRPr lang="en-CN"/>
-          </a:p>
-        </p:txBody>
-      </p:sp>
-      <p:sp>
-        <p:nvSpPr>
-          <p:cNvPr id="5" name="Text 3"/>
-          <p:cNvSpPr/>
-          <p:nvPr/>
-        </p:nvSpPr>
-        <p:spPr>
-          <a:xfrm>
-            <a:off x="548640" y="868680"/>
-            <a:ext cx="4846320" cy="228600"/>
-          </a:xfrm>
-          <a:prstGeom prst="rect">
-            <a:avLst/>
-          </a:prstGeom>
-          <a:noFill/>
-          <a:ln/>
-        </p:spPr>
-        <p:txBody>
-          <a:bodyPr wrap="square" lIns="0" tIns="0" rIns="0" bIns="0" rtlCol="0" anchor="ctr"/>
-          <a:lstStyle/>
-          <a:p>
-            <a:pPr marL="0" indent="0">
-              <a:buNone/>
-            </a:pPr>
-            <a:r>
-              <a:rPr lang="en-US" sz="1000" dirty="0">
-                <a:solidFill>
-                  <a:srgbClr val="666666"/>
-                </a:solidFill>
-                <a:latin typeface="Consolas" pitchFamily="34" charset="0"/>
-                <a:ea typeface="Consolas" pitchFamily="34" charset="-122"/>
-                <a:cs typeface="Consolas" pitchFamily="34" charset="-120"/>
-              </a:rPr>
-              <a:t># 1 — Install</a:t>
-            </a:r>
-            <a:endParaRPr lang="en-US" sz="1000" dirty="0"/>
-          </a:p>
-        </p:txBody>
-      </p:sp>
-      <p:sp>
-        <p:nvSpPr>
-          <p:cNvPr id="6" name="Text 4"/>
-          <p:cNvSpPr/>
-          <p:nvPr/>
-        </p:nvSpPr>
-        <p:spPr>
-          <a:xfrm>
-            <a:off x="548640" y="1143000"/>
-            <a:ext cx="4846320" cy="411480"/>
-          </a:xfrm>
-          <a:prstGeom prst="rect">
-            <a:avLst/>
-          </a:prstGeom>
-          <a:noFill/>
-          <a:ln/>
-        </p:spPr>
-        <p:txBody>
-          <a:bodyPr wrap="square" lIns="0" tIns="0" rIns="0" bIns="0" rtlCol="0" anchor="ctr"/>
-          <a:lstStyle/>
-          <a:p>
-            <a:pPr marL="0" indent="0">
-              <a:buNone/>
-            </a:pPr>
-            <a:r>
-              <a:rPr lang="en-US" sz="1000" b="1" dirty="0">
-                <a:solidFill>
-                  <a:srgbClr val="7EC8A4"/>
-                </a:solidFill>
-                <a:latin typeface="Consolas" pitchFamily="34" charset="0"/>
-                <a:ea typeface="Consolas" pitchFamily="34" charset="-122"/>
-                <a:cs typeface="Consolas" pitchFamily="34" charset="-120"/>
-              </a:rPr>
-              <a:t>$ pip install -e .</a:t>
-            </a:r>
-            <a:endParaRPr lang="en-US" sz="1000" dirty="0"/>
-          </a:p>
-        </p:txBody>
-      </p:sp>
-      <p:sp>
-        <p:nvSpPr>
-          <p:cNvPr id="7" name="Shape 5"/>
-          <p:cNvSpPr/>
-          <p:nvPr/>
-        </p:nvSpPr>
-        <p:spPr>
-          <a:xfrm>
-            <a:off x="365760" y="1783080"/>
-            <a:ext cx="5212080" cy="804672"/>
-          </a:xfrm>
-          <a:prstGeom prst="rect">
-            <a:avLst/>
-          </a:prstGeom>
-          <a:solidFill>
-            <a:srgbClr val="0F1933"/>
-          </a:solidFill>
-          <a:ln w="12700">
-            <a:solidFill>
-              <a:srgbClr val="333333"/>
-            </a:solidFill>
-            <a:prstDash val="solid"/>
-          </a:ln>
-        </p:spPr>
-        <p:txBody>
-          <a:bodyPr/>
-          <a:lstStyle/>
-          <a:p>
-            <a:endParaRPr lang="en-CN"/>
-          </a:p>
-        </p:txBody>
-      </p:sp>
-      <p:sp>
-        <p:nvSpPr>
-          <p:cNvPr id="8" name="Text 6"/>
-          <p:cNvSpPr/>
-          <p:nvPr/>
-        </p:nvSpPr>
-        <p:spPr>
-          <a:xfrm>
-            <a:off x="548640" y="1828800"/>
-            <a:ext cx="4846320" cy="228600"/>
-          </a:xfrm>
-          <a:prstGeom prst="rect">
-            <a:avLst/>
-          </a:prstGeom>
-          <a:noFill/>
-          <a:ln/>
-        </p:spPr>
-        <p:txBody>
-          <a:bodyPr wrap="square" lIns="0" tIns="0" rIns="0" bIns="0" rtlCol="0" anchor="ctr"/>
-          <a:lstStyle/>
-          <a:p>
-            <a:pPr marL="0" indent="0">
-              <a:buNone/>
-            </a:pPr>
-            <a:r>
-              <a:rPr lang="en-US" sz="1000" dirty="0">
-                <a:solidFill>
-                  <a:srgbClr val="666666"/>
-                </a:solidFill>
-                <a:latin typeface="Consolas" pitchFamily="34" charset="0"/>
-                <a:ea typeface="Consolas" pitchFamily="34" charset="-122"/>
-                <a:cs typeface="Consolas" pitchFamily="34" charset="-120"/>
-              </a:rPr>
-              <a:t># 2 — Run Method 3 (best)</a:t>
-            </a:r>
-            <a:endParaRPr lang="en-US" sz="1000" dirty="0"/>
-          </a:p>
-        </p:txBody>
-      </p:sp>
-      <p:sp>
-        <p:nvSpPr>
-          <p:cNvPr id="9" name="Text 7"/>
-          <p:cNvSpPr/>
-          <p:nvPr/>
-        </p:nvSpPr>
-        <p:spPr>
-          <a:xfrm>
-            <a:off x="548640" y="2103120"/>
-            <a:ext cx="4846320" cy="411480"/>
-          </a:xfrm>
-          <a:prstGeom prst="rect">
-            <a:avLst/>
-          </a:prstGeom>
-          <a:noFill/>
-          <a:ln/>
-        </p:spPr>
-        <p:txBody>
-          <a:bodyPr wrap="square" lIns="0" tIns="0" rIns="0" bIns="0" rtlCol="0" anchor="ctr"/>
-          <a:lstStyle/>
-          <a:p>
-            <a:pPr marL="0" indent="0">
-              <a:buNone/>
-            </a:pPr>
-            <a:r>
-              <a:rPr lang="en-US" sz="1000" b="1" dirty="0">
-                <a:solidFill>
-                  <a:srgbClr val="7EC8A4"/>
-                </a:solidFill>
-                <a:latin typeface="Consolas" pitchFamily="34" charset="0"/>
-                <a:ea typeface="Consolas" pitchFamily="34" charset="-122"/>
-                <a:cs typeface="Consolas" pitchFamily="34" charset="-120"/>
-              </a:rPr>
-              <a:t>$ segment-image --config configs/method_3_ews.json</a:t>
-            </a:r>
-            <a:endParaRPr lang="en-US" sz="1000" dirty="0"/>
-          </a:p>
-        </p:txBody>
-      </p:sp>
-      <p:sp>
-        <p:nvSpPr>
-          <p:cNvPr id="10" name="Shape 8"/>
-          <p:cNvSpPr/>
-          <p:nvPr/>
-        </p:nvSpPr>
-        <p:spPr>
-          <a:xfrm>
-            <a:off x="365760" y="2743200"/>
-            <a:ext cx="5212080" cy="804672"/>
-          </a:xfrm>
-          <a:prstGeom prst="rect">
-            <a:avLst/>
-          </a:prstGeom>
-          <a:solidFill>
-            <a:srgbClr val="33190F"/>
-          </a:solidFill>
-          <a:ln w="12700">
-            <a:solidFill>
-              <a:srgbClr val="333333"/>
-            </a:solidFill>
-            <a:prstDash val="solid"/>
-          </a:ln>
-        </p:spPr>
-        <p:txBody>
-          <a:bodyPr/>
-          <a:lstStyle/>
-          <a:p>
-            <a:endParaRPr lang="en-CN"/>
-          </a:p>
-        </p:txBody>
-      </p:sp>
-      <p:sp>
-        <p:nvSpPr>
-          <p:cNvPr id="11" name="Text 9"/>
-          <p:cNvSpPr/>
-          <p:nvPr/>
-        </p:nvSpPr>
-        <p:spPr>
-          <a:xfrm>
-            <a:off x="548640" y="2788920"/>
-            <a:ext cx="4846320" cy="228600"/>
-          </a:xfrm>
-          <a:prstGeom prst="rect">
-            <a:avLst/>
-          </a:prstGeom>
-          <a:noFill/>
-          <a:ln/>
-        </p:spPr>
-        <p:txBody>
-          <a:bodyPr wrap="square" lIns="0" tIns="0" rIns="0" bIns="0" rtlCol="0" anchor="ctr"/>
-          <a:lstStyle/>
-          <a:p>
-            <a:pPr marL="0" indent="0">
-              <a:buNone/>
-            </a:pPr>
-            <a:r>
-              <a:rPr lang="en-US" sz="1000" dirty="0">
-                <a:solidFill>
-                  <a:srgbClr val="666666"/>
-                </a:solidFill>
-                <a:latin typeface="Consolas" pitchFamily="34" charset="0"/>
-                <a:ea typeface="Consolas" pitchFamily="34" charset="-122"/>
-                <a:cs typeface="Consolas" pitchFamily="34" charset="-120"/>
-              </a:rPr>
-              <a:t># 3 — Robustness benchmark</a:t>
-            </a:r>
-            <a:endParaRPr lang="en-US" sz="1000" dirty="0"/>
-          </a:p>
-        </p:txBody>
-      </p:sp>
-      <p:sp>
-        <p:nvSpPr>
-          <p:cNvPr id="12" name="Text 10"/>
-          <p:cNvSpPr/>
-          <p:nvPr/>
-        </p:nvSpPr>
-        <p:spPr>
-          <a:xfrm>
-            <a:off x="548640" y="3063240"/>
-            <a:ext cx="4846320" cy="411480"/>
-          </a:xfrm>
-          <a:prstGeom prst="rect">
-            <a:avLst/>
-          </a:prstGeom>
-          <a:noFill/>
-          <a:ln/>
-        </p:spPr>
-        <p:txBody>
-          <a:bodyPr wrap="square" lIns="0" tIns="0" rIns="0" bIns="0" rtlCol="0" anchor="ctr"/>
-          <a:lstStyle/>
-          <a:p>
-            <a:pPr marL="0" indent="0">
-              <a:buNone/>
-            </a:pPr>
-            <a:r>
-              <a:rPr lang="en-US" sz="1000" b="1" dirty="0">
-                <a:solidFill>
-                  <a:srgbClr val="7EC8A4"/>
-                </a:solidFill>
-                <a:latin typeface="Consolas" pitchFamily="34" charset="0"/>
-                <a:ea typeface="Consolas" pitchFamily="34" charset="-122"/>
-                <a:cs typeface="Consolas" pitchFamily="34" charset="-120"/>
-              </a:rPr>
-              <a:t>$ PYTHONPATH=src python scripts/run_robustness.py</a:t>
-            </a:r>
-            <a:endParaRPr lang="en-US" sz="1000" dirty="0"/>
-          </a:p>
-        </p:txBody>
-      </p:sp>
-      <p:sp>
-        <p:nvSpPr>
-          <p:cNvPr id="13" name="Shape 11"/>
-          <p:cNvSpPr/>
-          <p:nvPr/>
-        </p:nvSpPr>
-        <p:spPr>
-          <a:xfrm>
-            <a:off x="365760" y="3703320"/>
-            <a:ext cx="5212080" cy="804672"/>
-          </a:xfrm>
-          <a:prstGeom prst="rect">
-            <a:avLst/>
-          </a:prstGeom>
-          <a:solidFill>
-            <a:srgbClr val="0F2419"/>
-          </a:solidFill>
-          <a:ln w="12700">
-            <a:solidFill>
-              <a:srgbClr val="333333"/>
-            </a:solidFill>
-            <a:prstDash val="solid"/>
-          </a:ln>
-        </p:spPr>
-        <p:txBody>
-          <a:bodyPr/>
-          <a:lstStyle/>
-          <a:p>
-            <a:endParaRPr lang="en-CN"/>
-          </a:p>
-        </p:txBody>
-      </p:sp>
-      <p:sp>
-        <p:nvSpPr>
-          <p:cNvPr id="14" name="Text 12"/>
-          <p:cNvSpPr/>
-          <p:nvPr/>
-        </p:nvSpPr>
-        <p:spPr>
-          <a:xfrm>
-            <a:off x="548640" y="3749040"/>
-            <a:ext cx="4846320" cy="228600"/>
-          </a:xfrm>
-          <a:prstGeom prst="rect">
-            <a:avLst/>
-          </a:prstGeom>
-          <a:noFill/>
-          <a:ln/>
-        </p:spPr>
-        <p:txBody>
-          <a:bodyPr wrap="square" lIns="0" tIns="0" rIns="0" bIns="0" rtlCol="0" anchor="ctr"/>
-          <a:lstStyle/>
-          <a:p>
-            <a:pPr marL="0" indent="0">
-              <a:buNone/>
-            </a:pPr>
-            <a:r>
-              <a:rPr lang="en-US" sz="1000" dirty="0">
-                <a:solidFill>
-                  <a:srgbClr val="666666"/>
-                </a:solidFill>
-                <a:latin typeface="Consolas" pitchFamily="34" charset="0"/>
-                <a:ea typeface="Consolas" pitchFamily="34" charset="-122"/>
-                <a:cs typeface="Consolas" pitchFamily="34" charset="-120"/>
-              </a:rPr>
-              <a:t># 4 — Data reduction</a:t>
-            </a:r>
-            <a:endParaRPr lang="en-US" sz="1000" dirty="0"/>
-          </a:p>
-        </p:txBody>
-      </p:sp>
-      <p:sp>
-        <p:nvSpPr>
-          <p:cNvPr id="15" name="Text 13"/>
-          <p:cNvSpPr/>
-          <p:nvPr/>
-        </p:nvSpPr>
-        <p:spPr>
-          <a:xfrm>
-            <a:off x="548640" y="4023360"/>
-            <a:ext cx="4846320" cy="411480"/>
-          </a:xfrm>
-          <a:prstGeom prst="rect">
-            <a:avLst/>
-          </a:prstGeom>
-          <a:noFill/>
-          <a:ln/>
-        </p:spPr>
-        <p:txBody>
-          <a:bodyPr wrap="square" lIns="0" tIns="0" rIns="0" bIns="0" rtlCol="0" anchor="ctr"/>
-          <a:lstStyle/>
-          <a:p>
-            <a:pPr marL="0" indent="0">
-              <a:buNone/>
-            </a:pPr>
-            <a:r>
-              <a:rPr lang="en-US" sz="1000" b="1" dirty="0">
-                <a:solidFill>
-                  <a:srgbClr val="7EC8A4"/>
-                </a:solidFill>
-                <a:latin typeface="Consolas" pitchFamily="34" charset="0"/>
-                <a:ea typeface="Consolas" pitchFamily="34" charset="-122"/>
-                <a:cs typeface="Consolas" pitchFamily="34" charset="-120"/>
-              </a:rPr>
-              <a:t>$ PYTHONPATH=src python scripts/run_data_reduction.py</a:t>
-            </a:r>
-            <a:endParaRPr lang="en-US" sz="1000" dirty="0"/>
-          </a:p>
-        </p:txBody>
-      </p:sp>
-      <p:sp>
-        <p:nvSpPr>
-          <p:cNvPr id="16" name="Shape 14"/>
-          <p:cNvSpPr/>
-          <p:nvPr/>
-        </p:nvSpPr>
-        <p:spPr>
-          <a:xfrm>
-            <a:off x="5760720" y="822960"/>
-            <a:ext cx="3108960" cy="3749040"/>
-          </a:xfrm>
-          <a:prstGeom prst="rect">
-            <a:avLst/>
-          </a:prstGeom>
-          <a:solidFill>
-            <a:srgbClr val="141414"/>
-          </a:solidFill>
-          <a:ln w="12700">
-            <a:solidFill>
-              <a:srgbClr val="444444"/>
-            </a:solidFill>
-            <a:prstDash val="solid"/>
-          </a:ln>
-        </p:spPr>
-        <p:txBody>
-          <a:bodyPr/>
-          <a:lstStyle/>
-          <a:p>
-            <a:endParaRPr lang="en-CN"/>
-          </a:p>
-        </p:txBody>
-      </p:sp>
-      <p:sp>
-        <p:nvSpPr>
-          <p:cNvPr id="17" name="Text 15"/>
-          <p:cNvSpPr/>
-          <p:nvPr/>
-        </p:nvSpPr>
-        <p:spPr>
-          <a:xfrm>
-            <a:off x="5852160" y="868680"/>
-            <a:ext cx="2926080" cy="320040"/>
-          </a:xfrm>
-          <a:prstGeom prst="rect">
-            <a:avLst/>
-          </a:prstGeom>
-          <a:noFill/>
-          <a:ln/>
-        </p:spPr>
-        <p:txBody>
-          <a:bodyPr wrap="square" lIns="0" tIns="0" rIns="0" bIns="0" rtlCol="0" anchor="ctr"/>
-          <a:lstStyle/>
-          <a:p>
-            <a:pPr marL="0" indent="0">
-              <a:buNone/>
-            </a:pPr>
-            <a:r>
-              <a:rPr lang="en-US" sz="1200" b="1" dirty="0">
-                <a:solidFill>
-                  <a:srgbClr val="52B788"/>
-                </a:solidFill>
-                <a:latin typeface="Calibri" pitchFamily="34" charset="0"/>
-                <a:ea typeface="Calibri" pitchFamily="34" charset="-122"/>
-                <a:cs typeface="Calibri" pitchFamily="34" charset="-120"/>
-              </a:rPr>
-              <a:t>Expected Outputs</a:t>
-            </a:r>
-            <a:endParaRPr lang="en-US" sz="1200" dirty="0"/>
-          </a:p>
-        </p:txBody>
-      </p:sp>
-      <p:sp>
-        <p:nvSpPr>
-          <p:cNvPr id="18" name="Text 16"/>
-          <p:cNvSpPr/>
-          <p:nvPr/>
-        </p:nvSpPr>
-        <p:spPr>
-          <a:xfrm>
-            <a:off x="5852160" y="1261872"/>
-            <a:ext cx="2926080" cy="3200400"/>
-          </a:xfrm>
-          <a:prstGeom prst="rect">
-            <a:avLst/>
-          </a:prstGeom>
-          <a:noFill/>
-          <a:ln/>
-        </p:spPr>
-        <p:txBody>
-          <a:bodyPr wrap="square" rtlCol="0" anchor="ctr"/>
-          <a:lstStyle/>
-          <a:p>
-            <a:pPr marL="0" indent="0">
-              <a:buNone/>
-            </a:pPr>
-            <a:r>
-              <a:rPr lang="en-US" sz="900" dirty="0">
-                <a:solidFill>
-                  <a:srgbClr val="CCCCCC"/>
-                </a:solidFill>
-                <a:latin typeface="Consolas" pitchFamily="34" charset="0"/>
-                <a:ea typeface="Consolas" pitchFamily="34" charset="-122"/>
-                <a:cs typeface="Consolas" pitchFamily="34" charset="-120"/>
-              </a:rPr>
-              <a:t>outputs/method_3/runs/…/test/</a:t>
-            </a:r>
-            <a:endParaRPr lang="en-US" sz="900" dirty="0"/>
-          </a:p>
-          <a:p>
-            <a:pPr marL="0" indent="0">
-              <a:buNone/>
-            </a:pPr>
-            <a:r>
-              <a:rPr lang="en-US" sz="900" dirty="0">
-                <a:solidFill>
-                  <a:srgbClr val="CCCCCC"/>
-                </a:solidFill>
-                <a:latin typeface="Consolas" pitchFamily="34" charset="0"/>
-                <a:ea typeface="Consolas" pitchFamily="34" charset="-122"/>
-                <a:cs typeface="Consolas" pitchFamily="34" charset="-120"/>
-              </a:rPr>
-              <a:t>  summary.json  (IoU = 0.874)</a:t>
-            </a:r>
-            <a:endParaRPr lang="en-US" sz="900" dirty="0"/>
-          </a:p>
-          <a:p>
-            <a:pPr marL="0" indent="0">
-              <a:buNone/>
-            </a:pPr>
-            <a:r>
-              <a:rPr lang="en-US" sz="900" dirty="0">
-                <a:solidFill>
-                  <a:srgbClr val="CCCCCC"/>
-                </a:solidFill>
-                <a:latin typeface="Consolas" pitchFamily="34" charset="0"/>
-                <a:ea typeface="Consolas" pitchFamily="34" charset="-122"/>
-                <a:cs typeface="Consolas" pitchFamily="34" charset="-120"/>
-              </a:rPr>
-              <a:t>  overlay/*.png  (segmentation overlay)</a:t>
-            </a:r>
-            <a:endParaRPr lang="en-US" sz="900" dirty="0"/>
-          </a:p>
-          <a:p>
-            <a:pPr marL="0" indent="0">
-              <a:buNone/>
-            </a:pPr>
-            <a:r>
-              <a:rPr lang="en-US" sz="900" dirty="0">
-                <a:solidFill>
-                  <a:srgbClr val="CCCCCC"/>
-                </a:solidFill>
-                <a:latin typeface="Consolas" pitchFamily="34" charset="0"/>
-                <a:ea typeface="Consolas" pitchFamily="34" charset="-122"/>
-                <a:cs typeface="Consolas" pitchFamily="34" charset="-120"/>
-              </a:rPr>
-              <a:t>  panel/*.png   (qualitative panel)</a:t>
-            </a:r>
-            <a:endParaRPr lang="en-US" sz="900" dirty="0"/>
-          </a:p>
-          <a:p>
-            <a:pPr marL="0" indent="0">
-              <a:buNone/>
-            </a:pPr>
-            <a:endParaRPr lang="en-US" sz="900" dirty="0"/>
-          </a:p>
-          <a:p>
-            <a:pPr marL="0" indent="0">
-              <a:buNone/>
-            </a:pPr>
-            <a:r>
-              <a:rPr lang="en-US" sz="900" dirty="0">
-                <a:solidFill>
-                  <a:srgbClr val="CCCCCC"/>
-                </a:solidFill>
-                <a:latin typeface="Consolas" pitchFamily="34" charset="0"/>
-                <a:ea typeface="Consolas" pitchFamily="34" charset="-122"/>
-                <a:cs typeface="Consolas" pitchFamily="34" charset="-120"/>
-              </a:rPr>
-              <a:t>outputs/robustness/</a:t>
-            </a:r>
-            <a:endParaRPr lang="en-US" sz="900" dirty="0"/>
-          </a:p>
-          <a:p>
-            <a:pPr marL="0" indent="0">
-              <a:buNone/>
-            </a:pPr>
-            <a:r>
-              <a:rPr lang="en-US" sz="900" dirty="0">
-                <a:solidFill>
-                  <a:srgbClr val="CCCCCC"/>
-                </a:solidFill>
-                <a:latin typeface="Consolas" pitchFamily="34" charset="0"/>
-                <a:ea typeface="Consolas" pitchFamily="34" charset="-122"/>
-                <a:cs typeface="Consolas" pitchFamily="34" charset="-120"/>
-              </a:rPr>
-              <a:t>  summary.json  (9×4 IoU table)</a:t>
-            </a:r>
-            <a:endParaRPr lang="en-US" sz="900" dirty="0"/>
-          </a:p>
-          <a:p>
-            <a:pPr marL="0" indent="0">
-              <a:buNone/>
-            </a:pPr>
-            <a:r>
-              <a:rPr lang="en-US" sz="900" dirty="0">
-                <a:solidFill>
-                  <a:srgbClr val="CCCCCC"/>
-                </a:solidFill>
-                <a:latin typeface="Consolas" pitchFamily="34" charset="0"/>
-                <a:ea typeface="Consolas" pitchFamily="34" charset="-122"/>
-                <a:cs typeface="Consolas" pitchFamily="34" charset="-120"/>
-              </a:rPr>
-              <a:t>  method_*/robustness_results.csv</a:t>
-            </a:r>
-            <a:endParaRPr lang="en-US" sz="900" dirty="0"/>
-          </a:p>
-          <a:p>
-            <a:pPr marL="0" indent="0">
-              <a:buNone/>
-            </a:pPr>
-            <a:endParaRPr lang="en-US" sz="900" dirty="0"/>
-          </a:p>
-          <a:p>
-            <a:pPr marL="0" indent="0">
-              <a:buNone/>
-            </a:pPr>
-            <a:r>
-              <a:rPr lang="en-US" sz="900" dirty="0">
-                <a:solidFill>
-                  <a:srgbClr val="CCCCCC"/>
-                </a:solidFill>
-                <a:latin typeface="Consolas" pitchFamily="34" charset="0"/>
-                <a:ea typeface="Consolas" pitchFamily="34" charset="-122"/>
-                <a:cs typeface="Consolas" pitchFamily="34" charset="-120"/>
-              </a:rPr>
-              <a:t>results/  (pre-computed, in repo)</a:t>
-            </a:r>
-            <a:endParaRPr lang="en-US" sz="900" dirty="0"/>
-          </a:p>
-          <a:p>
-            <a:pPr marL="0" indent="0">
-              <a:buNone/>
-            </a:pPr>
-            <a:r>
-              <a:rPr lang="en-US" sz="900" dirty="0">
-                <a:solidFill>
-                  <a:srgbClr val="CCCCCC"/>
-                </a:solidFill>
-                <a:latin typeface="Consolas" pitchFamily="34" charset="0"/>
-                <a:ea typeface="Consolas" pitchFamily="34" charset="-122"/>
-                <a:cs typeface="Consolas" pitchFamily="34" charset="-120"/>
-              </a:rPr>
-              <a:t>  for report reviewer cross-check</a:t>
-            </a:r>
-            <a:endParaRPr lang="en-US" sz="900" dirty="0"/>
-          </a:p>
-        </p:txBody>
-      </p:sp>
-    </p:spTree>
-  </p:cSld>
-  <p:clrMapOvr>
-    <a:masterClrMapping/>
-  </p:clrMapOvr>
-</p:sld>
-</file>
-
 <file path=ppt/slides/slide2.xml><?xml version="1.0" encoding="utf-8"?>
 <p:sld xmlns:a="http://schemas.openxmlformats.org/drawingml/2006/main" xmlns:r="http://schemas.openxmlformats.org/officeDocument/2006/relationships" xmlns:p="http://schemas.openxmlformats.org/presentationml/2006/main">
   <p:cSld name="Slide 2">
@@ -11308,194 +10677,6 @@
                 <a:cs typeface="Calibri" pitchFamily="34" charset="-120"/>
               </a:rPr>
               <a:t>Analysis, limitations, future work</a:t>
-            </a:r>
-            <a:endParaRPr lang="en-US" sz="1100" dirty="0"/>
-          </a:p>
-        </p:txBody>
-      </p:sp>
-      <p:sp>
-        <p:nvSpPr>
-          <p:cNvPr id="29" name="Shape 27"/>
-          <p:cNvSpPr/>
-          <p:nvPr/>
-        </p:nvSpPr>
-        <p:spPr>
-          <a:xfrm>
-            <a:off x="4754880" y="3575304"/>
-            <a:ext cx="4206240" cy="1188720"/>
-          </a:xfrm>
-          <a:prstGeom prst="rect">
-            <a:avLst/>
-          </a:prstGeom>
-          <a:solidFill>
-            <a:srgbClr val="FFFFFF"/>
-          </a:solidFill>
-          <a:ln w="6350">
-            <a:solidFill>
-              <a:srgbClr val="CCCCCC"/>
-            </a:solidFill>
-            <a:prstDash val="solid"/>
-          </a:ln>
-          <a:effectLst>
-            <a:outerShdw blurRad="50800" dist="25400" dir="8100000" algn="bl" rotWithShape="0">
-              <a:srgbClr val="000000">
-                <a:alpha val="12000"/>
-              </a:srgbClr>
-            </a:outerShdw>
-          </a:effectLst>
-        </p:spPr>
-        <p:txBody>
-          <a:bodyPr/>
-          <a:lstStyle/>
-          <a:p>
-            <a:endParaRPr lang="en-CN"/>
-          </a:p>
-        </p:txBody>
-      </p:sp>
-      <p:sp>
-        <p:nvSpPr>
-          <p:cNvPr id="30" name="Shape 28"/>
-          <p:cNvSpPr/>
-          <p:nvPr/>
-        </p:nvSpPr>
-        <p:spPr>
-          <a:xfrm>
-            <a:off x="4754880" y="3575304"/>
-            <a:ext cx="502920" cy="1188720"/>
-          </a:xfrm>
-          <a:prstGeom prst="rect">
-            <a:avLst/>
-          </a:prstGeom>
-          <a:solidFill>
-            <a:srgbClr val="1E3A2F"/>
-          </a:solidFill>
-          <a:ln w="12700">
-            <a:solidFill>
-              <a:srgbClr val="1E3A2F"/>
-            </a:solidFill>
-            <a:prstDash val="solid"/>
-          </a:ln>
-        </p:spPr>
-        <p:txBody>
-          <a:bodyPr/>
-          <a:lstStyle/>
-          <a:p>
-            <a:endParaRPr lang="en-CN"/>
-          </a:p>
-        </p:txBody>
-      </p:sp>
-      <p:sp>
-        <p:nvSpPr>
-          <p:cNvPr id="31" name="Text 29"/>
-          <p:cNvSpPr/>
-          <p:nvPr/>
-        </p:nvSpPr>
-        <p:spPr>
-          <a:xfrm>
-            <a:off x="4754880" y="3575304"/>
-            <a:ext cx="502920" cy="1188720"/>
-          </a:xfrm>
-          <a:prstGeom prst="rect">
-            <a:avLst/>
-          </a:prstGeom>
-          <a:noFill/>
-          <a:ln/>
-        </p:spPr>
-        <p:txBody>
-          <a:bodyPr wrap="square" lIns="0" tIns="0" rIns="0" bIns="0" rtlCol="0" anchor="ctr"/>
-          <a:lstStyle/>
-          <a:p>
-            <a:pPr marL="0" indent="0" algn="ctr">
-              <a:buNone/>
-            </a:pPr>
-            <a:r>
-              <a:rPr lang="en-US" sz="1600" b="1" dirty="0">
-                <a:solidFill>
-                  <a:srgbClr val="FFFFFF"/>
-                </a:solidFill>
-                <a:latin typeface="Calibri" pitchFamily="34" charset="0"/>
-                <a:ea typeface="Calibri" pitchFamily="34" charset="-122"/>
-                <a:cs typeface="Calibri" pitchFamily="34" charset="-120"/>
-              </a:rPr>
-              <a:t>06</a:t>
-            </a:r>
-            <a:endParaRPr lang="en-US" sz="1600" dirty="0"/>
-          </a:p>
-        </p:txBody>
-      </p:sp>
-      <p:sp>
-        <p:nvSpPr>
-          <p:cNvPr id="32" name="Text 30"/>
-          <p:cNvSpPr/>
-          <p:nvPr/>
-        </p:nvSpPr>
-        <p:spPr>
-          <a:xfrm>
-            <a:off x="5349240" y="3685032"/>
-            <a:ext cx="3474720" cy="411480"/>
-          </a:xfrm>
-          <a:prstGeom prst="rect">
-            <a:avLst/>
-          </a:prstGeom>
-          <a:noFill/>
-          <a:ln/>
-        </p:spPr>
-        <p:txBody>
-          <a:bodyPr wrap="square" lIns="0" tIns="0" rIns="0" bIns="0" rtlCol="0" anchor="ctr"/>
-          <a:lstStyle/>
-          <a:p>
-            <a:pPr marL="0" indent="0">
-              <a:buNone/>
-            </a:pPr>
-            <a:r>
-              <a:rPr lang="en-US" sz="1300" b="1" dirty="0">
-                <a:solidFill>
-                  <a:srgbClr val="1A1A1A"/>
-                </a:solidFill>
-                <a:latin typeface="Calibri" pitchFamily="34" charset="0"/>
-                <a:ea typeface="Calibri" pitchFamily="34" charset="-122"/>
-                <a:cs typeface="Calibri" pitchFamily="34" charset="-120"/>
-              </a:rPr>
-              <a:t>Demo</a:t>
-            </a:r>
-            <a:endParaRPr lang="en-US" sz="1300" dirty="0"/>
-          </a:p>
-        </p:txBody>
-      </p:sp>
-      <p:sp>
-        <p:nvSpPr>
-          <p:cNvPr id="33" name="Text 31"/>
-          <p:cNvSpPr/>
-          <p:nvPr/>
-        </p:nvSpPr>
-        <p:spPr>
-          <a:xfrm>
-            <a:off x="5349240" y="4169664"/>
-            <a:ext cx="3474720" cy="457200"/>
-          </a:xfrm>
-          <a:prstGeom prst="rect">
-            <a:avLst/>
-          </a:prstGeom>
-          <a:noFill/>
-          <a:ln/>
-        </p:spPr>
-        <p:txBody>
-          <a:bodyPr wrap="square" lIns="0" tIns="0" rIns="0" bIns="0" rtlCol="0" anchor="ctr"/>
-          <a:lstStyle/>
-          <a:p>
-            <a:pPr marL="0" indent="0">
-              <a:buNone/>
-            </a:pPr>
-            <a:r>
-              <a:rPr lang="en-US" sz="1100" dirty="0">
-                <a:solidFill>
-                  <a:srgbClr val="444444"/>
-                </a:solidFill>
-                <a:latin typeface="Calibri" pitchFamily="34" charset="0"/>
-                <a:ea typeface="Calibri" pitchFamily="34" charset="-122"/>
-                <a:cs typeface="Calibri" pitchFamily="34" charset="-120"/>
-              </a:rPr>
-              <a:t>Code walkthrough &amp; outputs</a:t>
             </a:r>
             <a:endParaRPr lang="en-US" sz="1100" dirty="0"/>
           </a:p>
@@ -11542,7 +10723,7 @@
         </p:nvSpPr>
         <p:spPr>
           <a:xfrm>
-            <a:off x="0" y="0"/>
+            <a:off x="0" y="64008"/>
             <a:ext cx="9144000" cy="685800"/>
           </a:xfrm>
           <a:prstGeom prst="rect">
@@ -11613,7 +10794,7 @@
         </p:nvSpPr>
         <p:spPr>
           <a:xfrm>
-            <a:off x="365760" y="822960"/>
+            <a:off x="274320" y="832104"/>
             <a:ext cx="4389120" cy="365760"/>
           </a:xfrm>
           <a:prstGeom prst="rect">
@@ -11714,7 +10895,7 @@
                 <a:ea typeface="Calibri" pitchFamily="34" charset="-122"/>
                 <a:cs typeface="Calibri" pitchFamily="34" charset="-120"/>
               </a:rPr>
-              <a:t>Distinguishes wheat from weeds automatically</a:t>
+              <a:t>Separates wheat plants from soil/background automatically</a:t>
             </a:r>
             <a:endParaRPr lang="en-US" sz="1300" dirty="0"/>
           </a:p>
@@ -11950,7 +11131,7 @@
         </p:nvSpPr>
         <p:spPr>
           <a:xfrm>
-            <a:off x="365760" y="3794760"/>
+            <a:off x="365760" y="3995928"/>
             <a:ext cx="8412480" cy="713232"/>
           </a:xfrm>
           <a:prstGeom prst="rect">
@@ -11982,7 +11163,7 @@
         </p:nvSpPr>
         <p:spPr>
           <a:xfrm>
-            <a:off x="548640" y="3794760"/>
+            <a:off x="914400" y="3982212"/>
             <a:ext cx="8046720" cy="713232"/>
           </a:xfrm>
           <a:prstGeom prst="rect">
@@ -13903,24 +13084,6 @@
                 <a:ea typeface="Calibri" pitchFamily="34" charset="-122"/>
                 <a:cs typeface="Calibri" pitchFamily="34" charset="-120"/>
               </a:rPr>
-              <a:t>DepthCropSeg++ (Zhang et al. 2026)</a:t>
-            </a:r>
-            <a:endParaRPr lang="en-US" sz="1100" dirty="0"/>
-          </a:p>
-          <a:p>
-            <a:pPr marL="342900" indent="-342900">
-              <a:buSzPct val="100000"/>
-              <a:buChar char="•"/>
-            </a:pPr>
-            <a:r>
-              <a:rPr lang="en-US" sz="1100" dirty="0">
-                <a:solidFill>
-                  <a:srgbClr val="444444"/>
-                </a:solidFill>
-                <a:latin typeface="Calibri" pitchFamily="34" charset="0"/>
-                <a:ea typeface="Calibri" pitchFamily="34" charset="-122"/>
-                <a:cs typeface="Calibri" pitchFamily="34" charset="-120"/>
-              </a:rPr>
               <a:t>Depth-informed pseudo-label segmentation</a:t>
             </a:r>
             <a:endParaRPr lang="en-US" sz="1100" dirty="0"/>
@@ -14922,124 +14085,6 @@
           </a:p>
         </p:txBody>
       </p:sp>
-      <p:sp>
-        <p:nvSpPr>
-          <p:cNvPr id="26" name="Shape 24"/>
-          <p:cNvSpPr/>
-          <p:nvPr/>
-        </p:nvSpPr>
-        <p:spPr>
-          <a:xfrm>
-            <a:off x="5687568" y="3694176"/>
-            <a:ext cx="0" cy="274320"/>
-          </a:xfrm>
-          <a:prstGeom prst="line">
-            <a:avLst/>
-          </a:prstGeom>
-          <a:noFill/>
-          <a:ln w="19050">
-            <a:solidFill>
-              <a:srgbClr val="52B788"/>
-            </a:solidFill>
-            <a:prstDash val="solid"/>
-          </a:ln>
-        </p:spPr>
-        <p:txBody>
-          <a:bodyPr/>
-          <a:lstStyle/>
-          <a:p>
-            <a:endParaRPr lang="en-CN"/>
-          </a:p>
-        </p:txBody>
-      </p:sp>
-      <p:sp>
-        <p:nvSpPr>
-          <p:cNvPr id="27" name="Shape 25"/>
-          <p:cNvSpPr/>
-          <p:nvPr/>
-        </p:nvSpPr>
-        <p:spPr>
-          <a:xfrm>
-            <a:off x="5486400" y="3968496"/>
-            <a:ext cx="402336" cy="402336"/>
-          </a:xfrm>
-          <a:prstGeom prst="ellipse">
-            <a:avLst/>
-          </a:prstGeom>
-          <a:solidFill>
-            <a:srgbClr val="1E3A2F"/>
-          </a:solidFill>
-          <a:ln w="12700">
-            <a:solidFill>
-              <a:srgbClr val="1E3A2F"/>
-            </a:solidFill>
-            <a:prstDash val="solid"/>
-          </a:ln>
-        </p:spPr>
-        <p:txBody>
-          <a:bodyPr/>
-          <a:lstStyle/>
-          <a:p>
-            <a:endParaRPr lang="en-CN"/>
-          </a:p>
-        </p:txBody>
-      </p:sp>
-      <p:sp>
-        <p:nvSpPr>
-          <p:cNvPr id="28" name="Text 26"/>
-          <p:cNvSpPr/>
-          <p:nvPr/>
-        </p:nvSpPr>
-        <p:spPr>
-          <a:xfrm>
-            <a:off x="5486400" y="3968496"/>
-            <a:ext cx="402336" cy="402336"/>
-          </a:xfrm>
-          <a:prstGeom prst="rect">
-            <a:avLst/>
-          </a:prstGeom>
-          <a:noFill/>
-          <a:ln/>
-        </p:spPr>
-        <p:txBody>
-          <a:bodyPr wrap="square" lIns="0" tIns="0" rIns="0" bIns="0" rtlCol="0" anchor="ctr"/>
-          <a:lstStyle/>
-          <a:p>
-            <a:pPr marL="0" indent="0" algn="ctr">
-              <a:buNone/>
-            </a:pPr>
-            <a:endParaRPr lang="en-US" sz="1200" dirty="0"/>
-          </a:p>
-        </p:txBody>
-      </p:sp>
-      <p:sp>
-        <p:nvSpPr>
-          <p:cNvPr id="29" name="Text 27"/>
-          <p:cNvSpPr/>
-          <p:nvPr/>
-        </p:nvSpPr>
-        <p:spPr>
-          <a:xfrm>
-            <a:off x="5989320" y="3995928"/>
-            <a:ext cx="2834640" cy="347472"/>
-          </a:xfrm>
-          <a:prstGeom prst="rect">
-            <a:avLst/>
-          </a:prstGeom>
-          <a:noFill/>
-          <a:ln/>
-        </p:spPr>
-        <p:txBody>
-          <a:bodyPr wrap="square" lIns="0" tIns="0" rIns="0" bIns="0" rtlCol="0" anchor="ctr"/>
-          <a:lstStyle/>
-          <a:p>
-            <a:pPr marL="0" indent="0">
-              <a:buNone/>
-            </a:pPr>
-            <a:endParaRPr lang="en-US" sz="1100" dirty="0"/>
-          </a:p>
-        </p:txBody>
-      </p:sp>
     </p:spTree>
   </p:cSld>
   <p:clrMapOvr>
@@ -15152,7 +14197,7 @@
         </p:nvSpPr>
         <p:spPr>
           <a:xfrm>
-            <a:off x="365760" y="822960"/>
+            <a:off x="548640" y="1120140"/>
             <a:ext cx="5303520" cy="347472"/>
           </a:xfrm>
           <a:prstGeom prst="rect">
@@ -15191,7 +14236,7 @@
         </p:nvSpPr>
         <p:spPr>
           <a:xfrm>
-            <a:off x="365760" y="1261872"/>
+            <a:off x="256032" y="1737360"/>
             <a:ext cx="1719072" cy="566928"/>
           </a:xfrm>
           <a:prstGeom prst="rect">
@@ -15223,7 +14268,7 @@
         </p:nvSpPr>
         <p:spPr>
           <a:xfrm>
-            <a:off x="365760" y="1261872"/>
+            <a:off x="256032" y="1737360"/>
             <a:ext cx="1719072" cy="182880"/>
           </a:xfrm>
           <a:prstGeom prst="rect">
@@ -15255,7 +14300,7 @@
         </p:nvSpPr>
         <p:spPr>
           <a:xfrm>
-            <a:off x="411480" y="1261872"/>
+            <a:off x="301752" y="1737360"/>
             <a:ext cx="1627632" cy="182880"/>
           </a:xfrm>
           <a:prstGeom prst="rect">
@@ -15294,7 +14339,7 @@
         </p:nvSpPr>
         <p:spPr>
           <a:xfrm>
-            <a:off x="411480" y="1463040"/>
+            <a:off x="301752" y="1938528"/>
             <a:ext cx="1627632" cy="310896"/>
           </a:xfrm>
           <a:prstGeom prst="rect">
@@ -15333,7 +14378,7 @@
         </p:nvSpPr>
         <p:spPr>
           <a:xfrm>
-            <a:off x="2212848" y="1261872"/>
+            <a:off x="2103120" y="1737360"/>
             <a:ext cx="1719072" cy="566928"/>
           </a:xfrm>
           <a:prstGeom prst="rect">
@@ -15365,7 +14410,7 @@
         </p:nvSpPr>
         <p:spPr>
           <a:xfrm>
-            <a:off x="2212848" y="1261872"/>
+            <a:off x="2103120" y="1737360"/>
             <a:ext cx="1719072" cy="182880"/>
           </a:xfrm>
           <a:prstGeom prst="rect">
@@ -15397,7 +14442,7 @@
         </p:nvSpPr>
         <p:spPr>
           <a:xfrm>
-            <a:off x="2258568" y="1261872"/>
+            <a:off x="2148840" y="1737360"/>
             <a:ext cx="1627632" cy="182880"/>
           </a:xfrm>
           <a:prstGeom prst="rect">
@@ -15436,7 +14481,7 @@
         </p:nvSpPr>
         <p:spPr>
           <a:xfrm>
-            <a:off x="2258568" y="1463040"/>
+            <a:off x="2148840" y="1938528"/>
             <a:ext cx="1627632" cy="310896"/>
           </a:xfrm>
           <a:prstGeom prst="rect">
@@ -15475,7 +14520,7 @@
         </p:nvSpPr>
         <p:spPr>
           <a:xfrm>
-            <a:off x="4059936" y="1261872"/>
+            <a:off x="3950208" y="1737360"/>
             <a:ext cx="1719072" cy="566928"/>
           </a:xfrm>
           <a:prstGeom prst="rect">
@@ -15507,7 +14552,7 @@
         </p:nvSpPr>
         <p:spPr>
           <a:xfrm>
-            <a:off x="4059936" y="1261872"/>
+            <a:off x="3950208" y="1737360"/>
             <a:ext cx="1719072" cy="182880"/>
           </a:xfrm>
           <a:prstGeom prst="rect">
@@ -15539,7 +14584,7 @@
         </p:nvSpPr>
         <p:spPr>
           <a:xfrm>
-            <a:off x="4105656" y="1261872"/>
+            <a:off x="3995928" y="1737360"/>
             <a:ext cx="1627632" cy="182880"/>
           </a:xfrm>
           <a:prstGeom prst="rect">
@@ -15578,7 +14623,7 @@
         </p:nvSpPr>
         <p:spPr>
           <a:xfrm>
-            <a:off x="4105656" y="1463040"/>
+            <a:off x="3995928" y="1938528"/>
             <a:ext cx="1627632" cy="310896"/>
           </a:xfrm>
           <a:prstGeom prst="rect">
@@ -15617,7 +14662,7 @@
         </p:nvSpPr>
         <p:spPr>
           <a:xfrm>
-            <a:off x="365760" y="1920240"/>
+            <a:off x="256032" y="2395728"/>
             <a:ext cx="1719072" cy="566928"/>
           </a:xfrm>
           <a:prstGeom prst="rect">
@@ -15649,7 +14694,7 @@
         </p:nvSpPr>
         <p:spPr>
           <a:xfrm>
-            <a:off x="365760" y="1920240"/>
+            <a:off x="256032" y="2395728"/>
             <a:ext cx="1719072" cy="182880"/>
           </a:xfrm>
           <a:prstGeom prst="rect">
@@ -15681,7 +14726,7 @@
         </p:nvSpPr>
         <p:spPr>
           <a:xfrm>
-            <a:off x="411480" y="1920240"/>
+            <a:off x="301752" y="2395728"/>
             <a:ext cx="1627632" cy="182880"/>
           </a:xfrm>
           <a:prstGeom prst="rect">
@@ -15720,7 +14765,7 @@
         </p:nvSpPr>
         <p:spPr>
           <a:xfrm>
-            <a:off x="411480" y="2121408"/>
+            <a:off x="301752" y="2596896"/>
             <a:ext cx="1627632" cy="310896"/>
           </a:xfrm>
           <a:prstGeom prst="rect">
@@ -15759,7 +14804,7 @@
         </p:nvSpPr>
         <p:spPr>
           <a:xfrm>
-            <a:off x="2212848" y="1920240"/>
+            <a:off x="2103120" y="2395728"/>
             <a:ext cx="1719072" cy="566928"/>
           </a:xfrm>
           <a:prstGeom prst="rect">
@@ -15791,7 +14836,7 @@
         </p:nvSpPr>
         <p:spPr>
           <a:xfrm>
-            <a:off x="2212848" y="1920240"/>
+            <a:off x="2103120" y="2395728"/>
             <a:ext cx="1719072" cy="182880"/>
           </a:xfrm>
           <a:prstGeom prst="rect">
@@ -15823,7 +14868,7 @@
         </p:nvSpPr>
         <p:spPr>
           <a:xfrm>
-            <a:off x="2258568" y="1920240"/>
+            <a:off x="2148840" y="2395728"/>
             <a:ext cx="1627632" cy="182880"/>
           </a:xfrm>
           <a:prstGeom prst="rect">
@@ -15862,7 +14907,7 @@
         </p:nvSpPr>
         <p:spPr>
           <a:xfrm>
-            <a:off x="2258568" y="2121408"/>
+            <a:off x="2148840" y="2596896"/>
             <a:ext cx="1627632" cy="310896"/>
           </a:xfrm>
           <a:prstGeom prst="rect">
@@ -15901,7 +14946,7 @@
         </p:nvSpPr>
         <p:spPr>
           <a:xfrm>
-            <a:off x="4059936" y="1920240"/>
+            <a:off x="3950208" y="2395728"/>
             <a:ext cx="1719072" cy="566928"/>
           </a:xfrm>
           <a:prstGeom prst="rect">
@@ -15933,7 +14978,7 @@
         </p:nvSpPr>
         <p:spPr>
           <a:xfrm>
-            <a:off x="4059936" y="1920240"/>
+            <a:off x="3950208" y="2395728"/>
             <a:ext cx="1719072" cy="182880"/>
           </a:xfrm>
           <a:prstGeom prst="rect">
@@ -15965,7 +15010,7 @@
         </p:nvSpPr>
         <p:spPr>
           <a:xfrm>
-            <a:off x="4105656" y="1920240"/>
+            <a:off x="3995928" y="2395728"/>
             <a:ext cx="1627632" cy="182880"/>
           </a:xfrm>
           <a:prstGeom prst="rect">
@@ -16004,7 +15049,7 @@
         </p:nvSpPr>
         <p:spPr>
           <a:xfrm>
-            <a:off x="4105656" y="2121408"/>
+            <a:off x="3995928" y="2596896"/>
             <a:ext cx="1627632" cy="310896"/>
           </a:xfrm>
           <a:prstGeom prst="rect">
@@ -16043,7 +15088,7 @@
         </p:nvSpPr>
         <p:spPr>
           <a:xfrm>
-            <a:off x="365760" y="2578608"/>
+            <a:off x="256032" y="3054096"/>
             <a:ext cx="1719072" cy="566928"/>
           </a:xfrm>
           <a:prstGeom prst="rect">
@@ -16075,7 +15120,7 @@
         </p:nvSpPr>
         <p:spPr>
           <a:xfrm>
-            <a:off x="365760" y="2578608"/>
+            <a:off x="256032" y="3054096"/>
             <a:ext cx="1719072" cy="182880"/>
           </a:xfrm>
           <a:prstGeom prst="rect">
@@ -16107,7 +15152,7 @@
         </p:nvSpPr>
         <p:spPr>
           <a:xfrm>
-            <a:off x="411480" y="2578608"/>
+            <a:off x="301752" y="3054096"/>
             <a:ext cx="1627632" cy="182880"/>
           </a:xfrm>
           <a:prstGeom prst="rect">
@@ -16146,7 +15191,7 @@
         </p:nvSpPr>
         <p:spPr>
           <a:xfrm>
-            <a:off x="411480" y="2779776"/>
+            <a:off x="301752" y="3255264"/>
             <a:ext cx="1627632" cy="310896"/>
           </a:xfrm>
           <a:prstGeom prst="rect">
@@ -16185,7 +15230,7 @@
         </p:nvSpPr>
         <p:spPr>
           <a:xfrm>
-            <a:off x="2212848" y="2578608"/>
+            <a:off x="2103120" y="3054096"/>
             <a:ext cx="1719072" cy="566928"/>
           </a:xfrm>
           <a:prstGeom prst="rect">
@@ -16217,7 +15262,7 @@
         </p:nvSpPr>
         <p:spPr>
           <a:xfrm>
-            <a:off x="2212848" y="2578608"/>
+            <a:off x="2103120" y="3054096"/>
             <a:ext cx="1719072" cy="182880"/>
           </a:xfrm>
           <a:prstGeom prst="rect">
@@ -16249,7 +15294,7 @@
         </p:nvSpPr>
         <p:spPr>
           <a:xfrm>
-            <a:off x="2258568" y="2578608"/>
+            <a:off x="2148840" y="3054096"/>
             <a:ext cx="1627632" cy="182880"/>
           </a:xfrm>
           <a:prstGeom prst="rect">
@@ -16288,7 +15333,7 @@
         </p:nvSpPr>
         <p:spPr>
           <a:xfrm>
-            <a:off x="2258568" y="2779776"/>
+            <a:off x="2148840" y="3255264"/>
             <a:ext cx="1627632" cy="310896"/>
           </a:xfrm>
           <a:prstGeom prst="rect">
@@ -16313,7 +15358,7 @@
                 <a:ea typeface="Calibri" pitchFamily="34" charset="-122"/>
                 <a:cs typeface="Calibri" pitchFamily="34" charset="-120"/>
               </a:rPr>
-              <a:t>Grey, local mean/std</a:t>
+              <a:t>Grey, local mean/var</a:t>
             </a:r>
             <a:endParaRPr lang="en-US" sz="900" dirty="0"/>
           </a:p>
@@ -16327,7 +15372,7 @@
         </p:nvSpPr>
         <p:spPr>
           <a:xfrm>
-            <a:off x="4059936" y="2578608"/>
+            <a:off x="3950208" y="3054096"/>
             <a:ext cx="1719072" cy="566928"/>
           </a:xfrm>
           <a:prstGeom prst="rect">
@@ -16359,7 +15404,7 @@
         </p:nvSpPr>
         <p:spPr>
           <a:xfrm>
-            <a:off x="4059936" y="2578608"/>
+            <a:off x="3950208" y="3054096"/>
             <a:ext cx="1719072" cy="182880"/>
           </a:xfrm>
           <a:prstGeom prst="rect">
@@ -16391,7 +15436,7 @@
         </p:nvSpPr>
         <p:spPr>
           <a:xfrm>
-            <a:off x="4105656" y="2578608"/>
+            <a:off x="3995928" y="3054096"/>
             <a:ext cx="1627632" cy="182880"/>
           </a:xfrm>
           <a:prstGeom prst="rect">
@@ -16430,7 +15475,7 @@
         </p:nvSpPr>
         <p:spPr>
           <a:xfrm>
-            <a:off x="4105656" y="2779776"/>
+            <a:off x="3995928" y="3255264"/>
             <a:ext cx="1627632" cy="310896"/>
           </a:xfrm>
           <a:prstGeom prst="rect">
@@ -18990,7 +18035,7 @@
                 <a:ea typeface="Calibri" pitchFamily="34" charset="-122"/>
                 <a:cs typeface="Calibri" pitchFamily="34" charset="-120"/>
               </a:rPr>
-              <a:t>Flip + colour jitter</a:t>
+              <a:t>Flip + colour jitter + Gaussian noise</a:t>
             </a:r>
             <a:endParaRPr lang="en-US" sz="1000" dirty="0"/>
           </a:p>
@@ -19070,7 +18115,13 @@
       </p:grpSpPr>
       <p:sp>
         <p:nvSpPr>
-          <p:cNvPr id="2" name="Shape 0"/>
+          <p:cNvPr id="22" name="Shape 0">
+            <a:extLst>
+              <a:ext uri="{FF2B5EF4-FFF2-40B4-BE49-F238E27FC236}">
+                <a16:creationId xmlns:a16="http://schemas.microsoft.com/office/drawing/2014/main" id="{7D22275E-E87E-FE8E-C6FF-AA8AC45B41B8}"/>
+              </a:ext>
+            </a:extLst>
+          </p:cNvPr>
           <p:cNvSpPr/>
           <p:nvPr/>
         </p:nvSpPr>
@@ -19083,11 +18134,11 @@
             <a:avLst/>
           </a:prstGeom>
           <a:solidFill>
-            <a:srgbClr val="4A1942"/>
+            <a:srgbClr val="1E3A2F"/>
           </a:solidFill>
           <a:ln w="12700">
             <a:solidFill>
-              <a:srgbClr val="4A1942"/>
+              <a:srgbClr val="1E3A2F"/>
             </a:solidFill>
             <a:prstDash val="solid"/>
           </a:ln>
@@ -19096,7 +18147,7 @@
           <a:bodyPr/>
           <a:lstStyle/>
           <a:p>
-            <a:endParaRPr lang="en-CN"/>
+            <a:endParaRPr lang="en-CN" dirty="0"/>
           </a:p>
         </p:txBody>
       </p:sp>

</xml_diff>